<commit_message>
Add new readme visuals
</commit_message>
<xml_diff>
--- a/Docs/process_indicator_flowchart.pptx
+++ b/Docs/process_indicator_flowchart.pptx
@@ -123,6 +123,114 @@
 </p:presentation>
 </file>
 
+<file path=ppt/changesInfos/changesInfo1.xml><?xml version="1.0" encoding="utf-8"?>
+<pc:chgInfo xmlns:a="http://schemas.openxmlformats.org/drawingml/2006/main" xmlns:r="http://schemas.openxmlformats.org/officeDocument/2006/relationships" xmlns:ac="http://schemas.microsoft.com/office/drawing/2013/main/command" xmlns:pc="http://schemas.microsoft.com/office/powerpoint/2013/main/command">
+  <pc:docChgLst>
+    <pc:chgData name="Alexis Athens" userId="1ea6108d-0ac8-4d94-9c4b-57fca604b282" providerId="ADAL" clId="{A06397AD-D0F3-450D-992F-317CAC305218}"/>
+    <pc:docChg chg="addSld delSld modSld">
+      <pc:chgData name="Alexis Athens" userId="1ea6108d-0ac8-4d94-9c4b-57fca604b282" providerId="ADAL" clId="{A06397AD-D0F3-450D-992F-317CAC305218}" dt="2026-09-07T14:17:42.701" v="4" actId="2696"/>
+      <pc:docMkLst>
+        <pc:docMk/>
+      </pc:docMkLst>
+      <pc:sldChg chg="addSp new del mod">
+        <pc:chgData name="Alexis Athens" userId="1ea6108d-0ac8-4d94-9c4b-57fca604b282" providerId="ADAL" clId="{A06397AD-D0F3-450D-992F-317CAC305218}" dt="2026-09-07T14:17:40.218" v="3" actId="2696"/>
+        <pc:sldMkLst>
+          <pc:docMk/>
+          <pc:sldMk cId="1566212509" sldId="257"/>
+        </pc:sldMkLst>
+        <pc:spChg chg="add">
+          <ac:chgData name="Alexis Athens" userId="1ea6108d-0ac8-4d94-9c4b-57fca604b282" providerId="ADAL" clId="{A06397AD-D0F3-450D-992F-317CAC305218}" dt="2026-09-07T14:17:19.791" v="2" actId="22"/>
+          <ac:spMkLst>
+            <pc:docMk/>
+            <pc:sldMk cId="1566212509" sldId="257"/>
+            <ac:spMk id="9" creationId="{89CBF2EF-F951-85FF-DC52-4C2B0A79BCF7}"/>
+          </ac:spMkLst>
+        </pc:spChg>
+        <pc:spChg chg="add">
+          <ac:chgData name="Alexis Athens" userId="1ea6108d-0ac8-4d94-9c4b-57fca604b282" providerId="ADAL" clId="{A06397AD-D0F3-450D-992F-317CAC305218}" dt="2026-09-07T14:17:19.791" v="2" actId="22"/>
+          <ac:spMkLst>
+            <pc:docMk/>
+            <pc:sldMk cId="1566212509" sldId="257"/>
+            <ac:spMk id="11" creationId="{EAA5CE28-0714-96A5-BE48-A9AF2C3C5357}"/>
+          </ac:spMkLst>
+        </pc:spChg>
+        <pc:spChg chg="add">
+          <ac:chgData name="Alexis Athens" userId="1ea6108d-0ac8-4d94-9c4b-57fca604b282" providerId="ADAL" clId="{A06397AD-D0F3-450D-992F-317CAC305218}" dt="2026-09-07T14:17:19.791" v="2" actId="22"/>
+          <ac:spMkLst>
+            <pc:docMk/>
+            <pc:sldMk cId="1566212509" sldId="257"/>
+            <ac:spMk id="15" creationId="{04BE4045-CB8D-81F6-1115-96A3741E730A}"/>
+          </ac:spMkLst>
+        </pc:spChg>
+        <pc:spChg chg="add">
+          <ac:chgData name="Alexis Athens" userId="1ea6108d-0ac8-4d94-9c4b-57fca604b282" providerId="ADAL" clId="{A06397AD-D0F3-450D-992F-317CAC305218}" dt="2026-09-07T14:17:19.791" v="2" actId="22"/>
+          <ac:spMkLst>
+            <pc:docMk/>
+            <pc:sldMk cId="1566212509" sldId="257"/>
+            <ac:spMk id="21" creationId="{07D740CB-9AA8-9D26-B26A-6516AD1F287D}"/>
+          </ac:spMkLst>
+        </pc:spChg>
+        <pc:spChg chg="add">
+          <ac:chgData name="Alexis Athens" userId="1ea6108d-0ac8-4d94-9c4b-57fca604b282" providerId="ADAL" clId="{A06397AD-D0F3-450D-992F-317CAC305218}" dt="2026-09-07T14:17:19.791" v="2" actId="22"/>
+          <ac:spMkLst>
+            <pc:docMk/>
+            <pc:sldMk cId="1566212509" sldId="257"/>
+            <ac:spMk id="23" creationId="{97250C20-90B1-BE86-C7B1-1488B09D2FC6}"/>
+          </ac:spMkLst>
+        </pc:spChg>
+        <pc:spChg chg="add">
+          <ac:chgData name="Alexis Athens" userId="1ea6108d-0ac8-4d94-9c4b-57fca604b282" providerId="ADAL" clId="{A06397AD-D0F3-450D-992F-317CAC305218}" dt="2026-09-07T14:17:19.791" v="2" actId="22"/>
+          <ac:spMkLst>
+            <pc:docMk/>
+            <pc:sldMk cId="1566212509" sldId="257"/>
+            <ac:spMk id="39" creationId="{C38BF17B-D25F-EF80-0A7E-C2BE129459AE}"/>
+          </ac:spMkLst>
+        </pc:spChg>
+        <pc:spChg chg="add">
+          <ac:chgData name="Alexis Athens" userId="1ea6108d-0ac8-4d94-9c4b-57fca604b282" providerId="ADAL" clId="{A06397AD-D0F3-450D-992F-317CAC305218}" dt="2026-09-07T14:17:19.791" v="2" actId="22"/>
+          <ac:spMkLst>
+            <pc:docMk/>
+            <pc:sldMk cId="1566212509" sldId="257"/>
+            <ac:spMk id="51" creationId="{23BF3270-E17C-5535-CB05-4606AD1545DD}"/>
+          </ac:spMkLst>
+        </pc:spChg>
+        <pc:spChg chg="add">
+          <ac:chgData name="Alexis Athens" userId="1ea6108d-0ac8-4d94-9c4b-57fca604b282" providerId="ADAL" clId="{A06397AD-D0F3-450D-992F-317CAC305218}" dt="2026-09-07T14:17:19.791" v="2" actId="22"/>
+          <ac:spMkLst>
+            <pc:docMk/>
+            <pc:sldMk cId="1566212509" sldId="257"/>
+            <ac:spMk id="59" creationId="{41479C51-5FAE-C1B1-4DC8-1D4F5FBB7561}"/>
+          </ac:spMkLst>
+        </pc:spChg>
+        <pc:spChg chg="add">
+          <ac:chgData name="Alexis Athens" userId="1ea6108d-0ac8-4d94-9c4b-57fca604b282" providerId="ADAL" clId="{A06397AD-D0F3-450D-992F-317CAC305218}" dt="2026-09-07T14:17:19.791" v="2" actId="22"/>
+          <ac:spMkLst>
+            <pc:docMk/>
+            <pc:sldMk cId="1566212509" sldId="257"/>
+            <ac:spMk id="75" creationId="{607A3D85-2F9B-1A55-96E9-4418194E19A4}"/>
+          </ac:spMkLst>
+        </pc:spChg>
+        <pc:spChg chg="add">
+          <ac:chgData name="Alexis Athens" userId="1ea6108d-0ac8-4d94-9c4b-57fca604b282" providerId="ADAL" clId="{A06397AD-D0F3-450D-992F-317CAC305218}" dt="2026-09-07T14:17:19.791" v="2" actId="22"/>
+          <ac:spMkLst>
+            <pc:docMk/>
+            <pc:sldMk cId="1566212509" sldId="257"/>
+            <ac:spMk id="95" creationId="{EE74C6E7-350D-DF40-F39B-A9DAEFA6193A}"/>
+          </ac:spMkLst>
+        </pc:spChg>
+      </pc:sldChg>
+      <pc:sldChg chg="new del">
+        <pc:chgData name="Alexis Athens" userId="1ea6108d-0ac8-4d94-9c4b-57fca604b282" providerId="ADAL" clId="{A06397AD-D0F3-450D-992F-317CAC305218}" dt="2026-09-07T14:17:42.701" v="4" actId="2696"/>
+        <pc:sldMkLst>
+          <pc:docMk/>
+          <pc:sldMk cId="474406563" sldId="258"/>
+        </pc:sldMkLst>
+      </pc:sldChg>
+    </pc:docChg>
+  </pc:docChgLst>
+</pc:chgInfo>
+</file>
+
 <file path=ppt/slideLayouts/slideLayout1.xml><?xml version="1.0" encoding="utf-8"?>
 <p:sldLayout xmlns:a="http://schemas.openxmlformats.org/drawingml/2006/main" xmlns:r="http://schemas.openxmlformats.org/officeDocument/2006/relationships" xmlns:p="http://schemas.openxmlformats.org/presentationml/2006/main" type="title" preserve="1">
   <p:cSld name="Title Slide">
@@ -302,7 +410,7 @@
           <a:p>
             <a:fld id="{5BCAD085-E8A6-8845-BD4E-CB4CCA059FC4}" type="datetimeFigureOut">
               <a:rPr lang="en-US" smtClean="0"/>
-              <a:t>11/26/2025</a:t>
+              <a:t>9/7/2026</a:t>
             </a:fld>
             <a:endParaRPr lang="en-US"/>
           </a:p>
@@ -470,7 +578,7 @@
           <a:p>
             <a:fld id="{5BCAD085-E8A6-8845-BD4E-CB4CCA059FC4}" type="datetimeFigureOut">
               <a:rPr lang="en-US" smtClean="0"/>
-              <a:t>11/26/2025</a:t>
+              <a:t>9/7/2026</a:t>
             </a:fld>
             <a:endParaRPr lang="en-US"/>
           </a:p>
@@ -648,7 +756,7 @@
           <a:p>
             <a:fld id="{5BCAD085-E8A6-8845-BD4E-CB4CCA059FC4}" type="datetimeFigureOut">
               <a:rPr lang="en-US" smtClean="0"/>
-              <a:t>11/26/2025</a:t>
+              <a:t>9/7/2026</a:t>
             </a:fld>
             <a:endParaRPr lang="en-US"/>
           </a:p>
@@ -816,7 +924,7 @@
           <a:p>
             <a:fld id="{5BCAD085-E8A6-8845-BD4E-CB4CCA059FC4}" type="datetimeFigureOut">
               <a:rPr lang="en-US" smtClean="0"/>
-              <a:t>11/26/2025</a:t>
+              <a:t>9/7/2026</a:t>
             </a:fld>
             <a:endParaRPr lang="en-US"/>
           </a:p>
@@ -1061,7 +1169,7 @@
           <a:p>
             <a:fld id="{5BCAD085-E8A6-8845-BD4E-CB4CCA059FC4}" type="datetimeFigureOut">
               <a:rPr lang="en-US" smtClean="0"/>
-              <a:t>11/26/2025</a:t>
+              <a:t>9/7/2026</a:t>
             </a:fld>
             <a:endParaRPr lang="en-US"/>
           </a:p>
@@ -1346,7 +1454,7 @@
           <a:p>
             <a:fld id="{5BCAD085-E8A6-8845-BD4E-CB4CCA059FC4}" type="datetimeFigureOut">
               <a:rPr lang="en-US" smtClean="0"/>
-              <a:t>11/26/2025</a:t>
+              <a:t>9/7/2026</a:t>
             </a:fld>
             <a:endParaRPr lang="en-US"/>
           </a:p>
@@ -1765,7 +1873,7 @@
           <a:p>
             <a:fld id="{5BCAD085-E8A6-8845-BD4E-CB4CCA059FC4}" type="datetimeFigureOut">
               <a:rPr lang="en-US" smtClean="0"/>
-              <a:t>11/26/2025</a:t>
+              <a:t>9/7/2026</a:t>
             </a:fld>
             <a:endParaRPr lang="en-US"/>
           </a:p>
@@ -1882,7 +1990,7 @@
           <a:p>
             <a:fld id="{5BCAD085-E8A6-8845-BD4E-CB4CCA059FC4}" type="datetimeFigureOut">
               <a:rPr lang="en-US" smtClean="0"/>
-              <a:t>11/26/2025</a:t>
+              <a:t>9/7/2026</a:t>
             </a:fld>
             <a:endParaRPr lang="en-US"/>
           </a:p>
@@ -1977,7 +2085,7 @@
           <a:p>
             <a:fld id="{5BCAD085-E8A6-8845-BD4E-CB4CCA059FC4}" type="datetimeFigureOut">
               <a:rPr lang="en-US" smtClean="0"/>
-              <a:t>11/26/2025</a:t>
+              <a:t>9/7/2026</a:t>
             </a:fld>
             <a:endParaRPr lang="en-US"/>
           </a:p>
@@ -2252,7 +2360,7 @@
           <a:p>
             <a:fld id="{5BCAD085-E8A6-8845-BD4E-CB4CCA059FC4}" type="datetimeFigureOut">
               <a:rPr lang="en-US" smtClean="0"/>
-              <a:t>11/26/2025</a:t>
+              <a:t>9/7/2026</a:t>
             </a:fld>
             <a:endParaRPr lang="en-US"/>
           </a:p>
@@ -2504,7 +2612,7 @@
           <a:p>
             <a:fld id="{5BCAD085-E8A6-8845-BD4E-CB4CCA059FC4}" type="datetimeFigureOut">
               <a:rPr lang="en-US" smtClean="0"/>
-              <a:t>11/26/2025</a:t>
+              <a:t>9/7/2026</a:t>
             </a:fld>
             <a:endParaRPr lang="en-US"/>
           </a:p>
@@ -2715,7 +2823,7 @@
           <a:p>
             <a:fld id="{5BCAD085-E8A6-8845-BD4E-CB4CCA059FC4}" type="datetimeFigureOut">
               <a:rPr lang="en-US" smtClean="0"/>
-              <a:t>11/26/2025</a:t>
+              <a:t>9/7/2026</a:t>
             </a:fld>
             <a:endParaRPr lang="en-US"/>
           </a:p>

</xml_diff>